<commit_message>
Fix garbled text in decks: use Korean charset for fonts
pptxgenjs writes CJK charsets (GB2312/Big5) on font tags, which made
PowerPoint render the diagram text as garbage.

Co-Authored-By: Claude Opus 5.5 <noreply@anthropic.com>
Claude-Session: https://claude.ai/code/session_016Y3Ye4fVWKqYEk23iT8H3o
</commit_message>
<xml_diff>
--- a/docs/Active_Assignment_Architecture.pptx
+++ b/docs/Active_Assignment_Architecture.pptx
@@ -3880,9 +3880,9 @@
                   <a:solidFill>
                     <a:srgbClr val="111827"/>
                   </a:solidFill>
-                  <a:latin typeface="Pretendard GOV" pitchFamily="34" charset="0"/>
-                  <a:ea typeface="Pretendard GOV" pitchFamily="34" charset="-122"/>
-                  <a:cs typeface="Pretendard GOV" pitchFamily="34" charset="-120"/>
+                  <a:latin typeface="Pretendard GOV" panose="02000503000000020004" pitchFamily="2" charset="-127"/>
+                  <a:ea typeface="Pretendard GOV" panose="02000503000000020004" pitchFamily="2" charset="-127"/>
+                  <a:cs typeface="Pretendard GOV" panose="02000503000000020004" pitchFamily="2" charset="-127"/>
                 </a:rPr>
                 <a:t>ACTIVE AUTO ASSIGNMENT ARCHITECTURE: </a:t>
               </a:r>
@@ -3894,9 +3894,9 @@
                   <a:solidFill>
                     <a:srgbClr val="2F6DB5"/>
                   </a:solidFill>
-                  <a:latin typeface="Pretendard GOV" pitchFamily="34" charset="0"/>
-                  <a:ea typeface="Pretendard GOV" pitchFamily="34" charset="-122"/>
-                  <a:cs typeface="Pretendard GOV" pitchFamily="34" charset="-120"/>
+                  <a:latin typeface="Pretendard GOV" panose="02000503000000020004" pitchFamily="2" charset="-127"/>
+                  <a:ea typeface="Pretendard GOV" panose="02000503000000020004" pitchFamily="2" charset="-127"/>
+                  <a:cs typeface="Pretendard GOV" panose="02000503000000020004" pitchFamily="2" charset="-127"/>
                 </a:rPr>
                 <a:t>ASSIGN</a:t>
               </a:r>
@@ -3908,9 +3908,9 @@
                   <a:solidFill>
                     <a:srgbClr val="111827"/>
                   </a:solidFill>
-                  <a:latin typeface="Pretendard GOV" pitchFamily="34" charset="0"/>
-                  <a:ea typeface="Pretendard GOV" pitchFamily="34" charset="-122"/>
-                  <a:cs typeface="Pretendard GOV" pitchFamily="34" charset="-120"/>
+                  <a:latin typeface="Pretendard GOV" panose="02000503000000020004" pitchFamily="2" charset="-127"/>
+                  <a:ea typeface="Pretendard GOV" panose="02000503000000020004" pitchFamily="2" charset="-127"/>
+                  <a:cs typeface="Pretendard GOV" panose="02000503000000020004" pitchFamily="2" charset="-127"/>
                 </a:rPr>
                 <a:t> → </a:t>
               </a:r>
@@ -3922,9 +3922,9 @@
                   <a:solidFill>
                     <a:srgbClr val="1E9E6A"/>
                   </a:solidFill>
-                  <a:latin typeface="Pretendard GOV" pitchFamily="34" charset="0"/>
-                  <a:ea typeface="Pretendard GOV" pitchFamily="34" charset="-122"/>
-                  <a:cs typeface="Pretendard GOV" pitchFamily="34" charset="-120"/>
+                  <a:latin typeface="Pretendard GOV" panose="02000503000000020004" pitchFamily="2" charset="-127"/>
+                  <a:ea typeface="Pretendard GOV" panose="02000503000000020004" pitchFamily="2" charset="-127"/>
+                  <a:cs typeface="Pretendard GOV" panose="02000503000000020004" pitchFamily="2" charset="-127"/>
                 </a:rPr>
                 <a:t>CLOSE</a:t>
               </a:r>
@@ -3961,9 +3961,9 @@
                   <a:solidFill>
                     <a:srgbClr val="374151"/>
                   </a:solidFill>
-                  <a:latin typeface="Pretendard GOV" pitchFamily="34" charset="0"/>
-                  <a:ea typeface="Pretendard GOV" pitchFamily="34" charset="-122"/>
-                  <a:cs typeface="Pretendard GOV" pitchFamily="34" charset="-120"/>
+                  <a:latin typeface="Pretendard GOV" panose="02000503000000020004" pitchFamily="2" charset="-127"/>
+                  <a:ea typeface="Pretendard GOV" panose="02000503000000020004" pitchFamily="2" charset="-127"/>
+                  <a:cs typeface="Pretendard GOV" panose="02000503000000020004" pitchFamily="2" charset="-127"/>
                 </a:rPr>
                 <a:t>Daily follow-up for 3P sellers who registered products but have no sales</a:t>
               </a:r>
@@ -4027,9 +4027,9 @@
                   <a:solidFill>
                     <a:srgbClr val="1F2A44"/>
                   </a:solidFill>
-                  <a:latin typeface="Pretendard GOV" pitchFamily="34" charset="0"/>
-                  <a:ea typeface="Pretendard GOV" pitchFamily="34" charset="-122"/>
-                  <a:cs typeface="Pretendard GOV" pitchFamily="34" charset="-120"/>
+                  <a:latin typeface="Pretendard GOV" panose="02000503000000020004" pitchFamily="2" charset="-127"/>
+                  <a:ea typeface="Pretendard GOV" panose="02000503000000020004" pitchFamily="2" charset="-127"/>
+                  <a:cs typeface="Pretendard GOV" panose="02000503000000020004" pitchFamily="2" charset="-127"/>
                 </a:rPr>
                 <a:t>SALESFORCE DATA</a:t>
               </a:r>
@@ -4093,9 +4093,9 @@
                   <a:solidFill>
                     <a:srgbClr val="1F2A44"/>
                   </a:solidFill>
-                  <a:latin typeface="Pretendard GOV" pitchFamily="34" charset="0"/>
-                  <a:ea typeface="Pretendard GOV" pitchFamily="34" charset="-122"/>
-                  <a:cs typeface="Pretendard GOV" pitchFamily="34" charset="-120"/>
+                  <a:latin typeface="Pretendard GOV" panose="02000503000000020004" pitchFamily="2" charset="-127"/>
+                  <a:ea typeface="Pretendard GOV" panose="02000503000000020004" pitchFamily="2" charset="-127"/>
+                  <a:cs typeface="Pretendard GOV" panose="02000503000000020004" pitchFamily="2" charset="-127"/>
                 </a:rPr>
                 <a:t>APEX AUTOMATION</a:t>
               </a:r>
@@ -4159,9 +4159,9 @@
                   <a:solidFill>
                     <a:srgbClr val="1F2A44"/>
                   </a:solidFill>
-                  <a:latin typeface="Pretendard GOV" pitchFamily="34" charset="0"/>
-                  <a:ea typeface="Pretendard GOV" pitchFamily="34" charset="-122"/>
-                  <a:cs typeface="Pretendard GOV" pitchFamily="34" charset="-120"/>
+                  <a:latin typeface="Pretendard GOV" panose="02000503000000020004" pitchFamily="2" charset="-127"/>
+                  <a:ea typeface="Pretendard GOV" panose="02000503000000020004" pitchFamily="2" charset="-127"/>
+                  <a:cs typeface="Pretendard GOV" panose="02000503000000020004" pitchFamily="2" charset="-127"/>
                 </a:rPr>
                 <a:t>RESULT</a:t>
               </a:r>
@@ -4225,9 +4225,9 @@
                   <a:solidFill>
                     <a:srgbClr val="1F2A44"/>
                   </a:solidFill>
-                  <a:latin typeface="Pretendard GOV" pitchFamily="34" charset="0"/>
-                  <a:ea typeface="Pretendard GOV" pitchFamily="34" charset="-122"/>
-                  <a:cs typeface="Pretendard GOV" pitchFamily="34" charset="-120"/>
+                  <a:latin typeface="Pretendard GOV" panose="02000503000000020004" pitchFamily="2" charset="-127"/>
+                  <a:ea typeface="Pretendard GOV" panose="02000503000000020004" pitchFamily="2" charset="-127"/>
+                  <a:cs typeface="Pretendard GOV" panose="02000503000000020004" pitchFamily="2" charset="-127"/>
                 </a:rPr>
                 <a:t>Account</a:t>
               </a:r>
@@ -4242,9 +4242,9 @@
                   <a:solidFill>
                     <a:srgbClr val="6B7280"/>
                   </a:solidFill>
-                  <a:latin typeface="Pretendard GOV" pitchFamily="34" charset="0"/>
-                  <a:ea typeface="Pretendard GOV" pitchFamily="34" charset="-122"/>
-                  <a:cs typeface="Pretendard GOV" pitchFamily="34" charset="-120"/>
+                  <a:latin typeface="Pretendard GOV" panose="02000503000000020004" pitchFamily="2" charset="-127"/>
+                  <a:ea typeface="Pretendard GOV" panose="02000503000000020004" pitchFamily="2" charset="-127"/>
+                  <a:cs typeface="Pretendard GOV" panose="02000503000000020004" pitchFamily="2" charset="-127"/>
                 </a:rPr>
                 <a:t>3P · D-10 product reg.</a:t>
               </a:r>
@@ -4259,9 +4259,9 @@
                   <a:solidFill>
                     <a:srgbClr val="6B7280"/>
                   </a:solidFill>
-                  <a:latin typeface="Pretendard GOV" pitchFamily="34" charset="0"/>
-                  <a:ea typeface="Pretendard GOV" pitchFamily="34" charset="-122"/>
-                  <a:cs typeface="Pretendard GOV" pitchFamily="34" charset="-120"/>
+                  <a:latin typeface="Pretendard GOV" panose="02000503000000020004" pitchFamily="2" charset="-127"/>
+                  <a:ea typeface="Pretendard GOV" panose="02000503000000020004" pitchFamily="2" charset="-127"/>
+                  <a:cs typeface="Pretendard GOV" panose="02000503000000020004" pitchFamily="2" charset="-127"/>
                 </a:rPr>
                 <a:t>no first order</a:t>
               </a:r>
@@ -4325,9 +4325,9 @@
                   <a:solidFill>
                     <a:srgbClr val="1F2A44"/>
                   </a:solidFill>
-                  <a:latin typeface="Pretendard GOV" pitchFamily="34" charset="0"/>
-                  <a:ea typeface="Pretendard GOV" pitchFamily="34" charset="-122"/>
-                  <a:cs typeface="Pretendard GOV" pitchFamily="34" charset="-120"/>
+                  <a:latin typeface="Pretendard GOV" panose="02000503000000020004" pitchFamily="2" charset="-127"/>
+                  <a:ea typeface="Pretendard GOV" panose="02000503000000020004" pitchFamily="2" charset="-127"/>
+                  <a:cs typeface="Pretendard GOV" panose="02000503000000020004" pitchFamily="2" charset="-127"/>
                 </a:rPr>
                 <a:t>User / Event</a:t>
               </a:r>
@@ -4342,9 +4342,9 @@
                   <a:solidFill>
                     <a:srgbClr val="6B7280"/>
                   </a:solidFill>
-                  <a:latin typeface="Pretendard GOV" pitchFamily="34" charset="0"/>
-                  <a:ea typeface="Pretendard GOV" pitchFamily="34" charset="-122"/>
-                  <a:cs typeface="Pretendard GOV" pitchFamily="34" charset="-120"/>
+                  <a:latin typeface="Pretendard GOV" panose="02000503000000020004" pitchFamily="2" charset="-127"/>
+                  <a:ea typeface="Pretendard GOV" panose="02000503000000020004" pitchFamily="2" charset="-127"/>
+                  <a:cs typeface="Pretendard GOV" panose="02000503000000020004" pitchFamily="2" charset="-127"/>
                 </a:rPr>
                 <a:t>Emerging MMA · A/B/C</a:t>
               </a:r>
@@ -4359,9 +4359,9 @@
                   <a:solidFill>
                     <a:srgbClr val="6B7280"/>
                   </a:solidFill>
-                  <a:latin typeface="Pretendard GOV" pitchFamily="34" charset="0"/>
-                  <a:ea typeface="Pretendard GOV" pitchFamily="34" charset="-122"/>
-                  <a:cs typeface="Pretendard GOV" pitchFamily="34" charset="-120"/>
+                  <a:latin typeface="Pretendard GOV" panose="02000503000000020004" pitchFamily="2" charset="-127"/>
+                  <a:ea typeface="Pretendard GOV" panose="02000503000000020004" pitchFamily="2" charset="-127"/>
+                  <a:cs typeface="Pretendard GOV" panose="02000503000000020004" pitchFamily="2" charset="-127"/>
                 </a:rPr>
                 <a:t>vacation excluded</a:t>
               </a:r>
@@ -4425,9 +4425,9 @@
                   <a:solidFill>
                     <a:srgbClr val="1F2A44"/>
                   </a:solidFill>
-                  <a:latin typeface="Pretendard GOV" pitchFamily="34" charset="0"/>
-                  <a:ea typeface="Pretendard GOV" pitchFamily="34" charset="-122"/>
-                  <a:cs typeface="Pretendard GOV" pitchFamily="34" charset="-120"/>
+                  <a:latin typeface="Pretendard GOV" panose="02000503000000020004" pitchFamily="2" charset="-127"/>
+                  <a:ea typeface="Pretendard GOV" panose="02000503000000020004" pitchFamily="2" charset="-127"/>
+                  <a:cs typeface="Pretendard GOV" panose="02000503000000020004" pitchFamily="2" charset="-127"/>
                 </a:rPr>
                 <a:t>Config</a:t>
               </a:r>
@@ -4442,9 +4442,9 @@
                   <a:solidFill>
                     <a:srgbClr val="6B7280"/>
                   </a:solidFill>
-                  <a:latin typeface="Pretendard GOV" pitchFamily="34" charset="0"/>
-                  <a:ea typeface="Pretendard GOV" pitchFamily="34" charset="-122"/>
-                  <a:cs typeface="Pretendard GOV" pitchFamily="34" charset="-120"/>
+                  <a:latin typeface="Pretendard GOV" panose="02000503000000020004" pitchFamily="2" charset="-127"/>
+                  <a:ea typeface="Pretendard GOV" panose="02000503000000020004" pitchFamily="2" charset="-127"/>
+                  <a:cs typeface="Pretendard GOV" panose="02000503000000020004" pitchFamily="2" charset="-127"/>
                 </a:rPr>
                 <a:t>Group % (Custom Setting)</a:t>
               </a:r>
@@ -4459,9 +4459,9 @@
                   <a:solidFill>
                     <a:srgbClr val="6B7280"/>
                   </a:solidFill>
-                  <a:latin typeface="Pretendard GOV" pitchFamily="34" charset="0"/>
-                  <a:ea typeface="Pretendard GOV" pitchFamily="34" charset="-122"/>
-                  <a:cs typeface="Pretendard GOV" pitchFamily="34" charset="-120"/>
+                  <a:latin typeface="Pretendard GOV" panose="02000503000000020004" pitchFamily="2" charset="-127"/>
+                  <a:ea typeface="Pretendard GOV" panose="02000503000000020004" pitchFamily="2" charset="-127"/>
+                  <a:cs typeface="Pretendard GOV" panose="02000503000000020004" pitchFamily="2" charset="-127"/>
                 </a:rPr>
                 <a:t>D-day (Custom Label)</a:t>
               </a:r>
@@ -4525,9 +4525,9 @@
                   <a:solidFill>
                     <a:srgbClr val="374151"/>
                   </a:solidFill>
-                  <a:latin typeface="Pretendard GOV" pitchFamily="34" charset="0"/>
-                  <a:ea typeface="Pretendard GOV" pitchFamily="34" charset="-122"/>
-                  <a:cs typeface="Pretendard GOV" pitchFamily="34" charset="-120"/>
+                  <a:latin typeface="Pretendard GOV" panose="02000503000000020004" pitchFamily="2" charset="-127"/>
+                  <a:ea typeface="Pretendard GOV" panose="02000503000000020004" pitchFamily="2" charset="-127"/>
+                  <a:cs typeface="Pretendard GOV" panose="02000503000000020004" pitchFamily="2" charset="-127"/>
                 </a:rPr>
                 <a:t>MMA-PR owners and</a:t>
               </a:r>
@@ -4542,9 +4542,9 @@
                   <a:solidFill>
                     <a:srgbClr val="374151"/>
                   </a:solidFill>
-                  <a:latin typeface="Pretendard GOV" pitchFamily="34" charset="0"/>
-                  <a:ea typeface="Pretendard GOV" pitchFamily="34" charset="-122"/>
-                  <a:cs typeface="Pretendard GOV" pitchFamily="34" charset="-120"/>
+                  <a:latin typeface="Pretendard GOV" panose="02000503000000020004" pitchFamily="2" charset="-127"/>
+                  <a:ea typeface="Pretendard GOV" panose="02000503000000020004" pitchFamily="2" charset="-127"/>
+                  <a:cs typeface="Pretendard GOV" panose="02000503000000020004" pitchFamily="2" charset="-127"/>
                 </a:rPr>
                 <a:t>'유한회사' are excluded</a:t>
               </a:r>
@@ -4581,9 +4581,9 @@
                   <a:solidFill>
                     <a:srgbClr val="2F6DB5"/>
                   </a:solidFill>
-                  <a:latin typeface="Pretendard GOV" pitchFamily="34" charset="0"/>
-                  <a:ea typeface="Pretendard GOV" pitchFamily="34" charset="-122"/>
-                  <a:cs typeface="Pretendard GOV" pitchFamily="34" charset="-120"/>
+                  <a:latin typeface="Pretendard GOV" panose="02000503000000020004" pitchFamily="2" charset="-127"/>
+                  <a:ea typeface="Pretendard GOV" panose="02000503000000020004" pitchFamily="2" charset="-127"/>
+                  <a:cs typeface="Pretendard GOV" panose="02000503000000020004" pitchFamily="2" charset="-127"/>
                 </a:rPr>
                 <a:t>Daily 09:00</a:t>
               </a:r>
@@ -4647,9 +4647,9 @@
                   <a:solidFill>
                     <a:srgbClr val="FFFFFF"/>
                   </a:solidFill>
-                  <a:latin typeface="Pretendard GOV" pitchFamily="34" charset="0"/>
-                  <a:ea typeface="Pretendard GOV" pitchFamily="34" charset="-122"/>
-                  <a:cs typeface="Pretendard GOV" pitchFamily="34" charset="-120"/>
+                  <a:latin typeface="Pretendard GOV" panose="02000503000000020004" pitchFamily="2" charset="-127"/>
+                  <a:ea typeface="Pretendard GOV" panose="02000503000000020004" pitchFamily="2" charset="-127"/>
+                  <a:cs typeface="Pretendard GOV" panose="02000503000000020004" pitchFamily="2" charset="-127"/>
                 </a:rPr>
                 <a:t>Assign Batch</a:t>
               </a:r>
@@ -4664,9 +4664,9 @@
                   <a:solidFill>
                     <a:srgbClr val="FFFFFF"/>
                   </a:solidFill>
-                  <a:latin typeface="Pretendard GOV" pitchFamily="34" charset="0"/>
-                  <a:ea typeface="Pretendard GOV" pitchFamily="34" charset="-122"/>
-                  <a:cs typeface="Pretendard GOV" pitchFamily="34" charset="-120"/>
+                  <a:latin typeface="Pretendard GOV" panose="02000503000000020004" pitchFamily="2" charset="-127"/>
+                  <a:ea typeface="Pretendard GOV" panose="02000503000000020004" pitchFamily="2" charset="-127"/>
+                  <a:cs typeface="Pretendard GOV" panose="02000503000000020004" pitchFamily="2" charset="-127"/>
                 </a:rPr>
                 <a:t>Active_Assignment_02_ba</a:t>
               </a:r>
@@ -4730,9 +4730,9 @@
                   <a:solidFill>
                     <a:srgbClr val="FFFFFF"/>
                   </a:solidFill>
-                  <a:latin typeface="Pretendard GOV" pitchFamily="34" charset="0"/>
-                  <a:ea typeface="Pretendard GOV" pitchFamily="34" charset="-122"/>
-                  <a:cs typeface="Pretendard GOV" pitchFamily="34" charset="-120"/>
+                  <a:latin typeface="Pretendard GOV" panose="02000503000000020004" pitchFamily="2" charset="-127"/>
+                  <a:ea typeface="Pretendard GOV" panose="02000503000000020004" pitchFamily="2" charset="-127"/>
+                  <a:cs typeface="Pretendard GOV" panose="02000503000000020004" pitchFamily="2" charset="-127"/>
                 </a:rPr>
                 <a:t>Allocator</a:t>
               </a:r>
@@ -4747,9 +4747,9 @@
                   <a:solidFill>
                     <a:srgbClr val="FFFFFF"/>
                   </a:solidFill>
-                  <a:latin typeface="Pretendard GOV" pitchFamily="34" charset="0"/>
-                  <a:ea typeface="Pretendard GOV" pitchFamily="34" charset="-122"/>
-                  <a:cs typeface="Pretendard GOV" pitchFamily="34" charset="-120"/>
+                  <a:latin typeface="Pretendard GOV" panose="02000503000000020004" pitchFamily="2" charset="-127"/>
+                  <a:ea typeface="Pretendard GOV" panose="02000503000000020004" pitchFamily="2" charset="-127"/>
+                  <a:cs typeface="Pretendard GOV" panose="02000503000000020004" pitchFamily="2" charset="-127"/>
                 </a:rPr>
                 <a:t>Active_Assignment_</a:t>
               </a:r>
@@ -4764,9 +4764,9 @@
                   <a:solidFill>
                     <a:srgbClr val="FFFFFF"/>
                   </a:solidFill>
-                  <a:latin typeface="Pretendard GOV" pitchFamily="34" charset="0"/>
-                  <a:ea typeface="Pretendard GOV" pitchFamily="34" charset="-122"/>
-                  <a:cs typeface="Pretendard GOV" pitchFamily="34" charset="-120"/>
+                  <a:latin typeface="Pretendard GOV" panose="02000503000000020004" pitchFamily="2" charset="-127"/>
+                  <a:ea typeface="Pretendard GOV" panose="02000503000000020004" pitchFamily="2" charset="-127"/>
+                  <a:cs typeface="Pretendard GOV" panose="02000503000000020004" pitchFamily="2" charset="-127"/>
                 </a:rPr>
                 <a:t>Helper</a:t>
               </a:r>
@@ -4855,9 +4855,9 @@
                   <a:solidFill>
                     <a:srgbClr val="374151"/>
                   </a:solidFill>
-                  <a:latin typeface="Pretendard GOV" pitchFamily="34" charset="0"/>
-                  <a:ea typeface="Pretendard GOV" pitchFamily="34" charset="-122"/>
-                  <a:cs typeface="Pretendard GOV" pitchFamily="34" charset="-120"/>
+                  <a:latin typeface="Pretendard GOV" panose="02000503000000020004" pitchFamily="2" charset="-127"/>
+                  <a:ea typeface="Pretendard GOV" panose="02000503000000020004" pitchFamily="2" charset="-127"/>
+                  <a:cs typeface="Pretendard GOV" panose="02000503000000020004" pitchFamily="2" charset="-127"/>
                 </a:rPr>
                 <a:t>A/B/C grade ratio ·</a:t>
               </a:r>
@@ -4872,9 +4872,9 @@
                   <a:solidFill>
                     <a:srgbClr val="374151"/>
                   </a:solidFill>
-                  <a:latin typeface="Pretendard GOV" pitchFamily="34" charset="0"/>
-                  <a:ea typeface="Pretendard GOV" pitchFamily="34" charset="-122"/>
-                  <a:cs typeface="Pretendard GOV" pitchFamily="34" charset="-120"/>
+                  <a:latin typeface="Pretendard GOV" panose="02000503000000020004" pitchFamily="2" charset="-127"/>
+                  <a:ea typeface="Pretendard GOV" panose="02000503000000020004" pitchFamily="2" charset="-127"/>
+                  <a:cs typeface="Pretendard GOV" panose="02000503000000020004" pitchFamily="2" charset="-127"/>
                 </a:rPr>
                 <a:t>least-loaded user first</a:t>
               </a:r>
@@ -4911,9 +4911,9 @@
                   <a:solidFill>
                     <a:srgbClr val="2F6DB5"/>
                   </a:solidFill>
-                  <a:latin typeface="Pretendard GOV" pitchFamily="34" charset="0"/>
-                  <a:ea typeface="Pretendard GOV" pitchFamily="34" charset="-122"/>
-                  <a:cs typeface="Pretendard GOV" pitchFamily="34" charset="-120"/>
+                  <a:latin typeface="Pretendard GOV" panose="02000503000000020004" pitchFamily="2" charset="-127"/>
+                  <a:ea typeface="Pretendard GOV" panose="02000503000000020004" pitchFamily="2" charset="-127"/>
+                  <a:cs typeface="Pretendard GOV" panose="02000503000000020004" pitchFamily="2" charset="-127"/>
                 </a:rPr>
                 <a:t>Scheduled</a:t>
               </a:r>
@@ -4977,9 +4977,9 @@
                   <a:solidFill>
                     <a:srgbClr val="FFFFFF"/>
                   </a:solidFill>
-                  <a:latin typeface="Pretendard GOV" pitchFamily="34" charset="0"/>
-                  <a:ea typeface="Pretendard GOV" pitchFamily="34" charset="-122"/>
-                  <a:cs typeface="Pretendard GOV" pitchFamily="34" charset="-120"/>
+                  <a:latin typeface="Pretendard GOV" panose="02000503000000020004" pitchFamily="2" charset="-127"/>
+                  <a:ea typeface="Pretendard GOV" panose="02000503000000020004" pitchFamily="2" charset="-127"/>
+                  <a:cs typeface="Pretendard GOV" panose="02000503000000020004" pitchFamily="2" charset="-127"/>
                 </a:rPr>
                 <a:t>Close Batch</a:t>
               </a:r>
@@ -4994,9 +4994,9 @@
                   <a:solidFill>
                     <a:srgbClr val="FFFFFF"/>
                   </a:solidFill>
-                  <a:latin typeface="Pretendard GOV" pitchFamily="34" charset="0"/>
-                  <a:ea typeface="Pretendard GOV" pitchFamily="34" charset="-122"/>
-                  <a:cs typeface="Pretendard GOV" pitchFamily="34" charset="-120"/>
+                  <a:latin typeface="Pretendard GOV" panose="02000503000000020004" pitchFamily="2" charset="-127"/>
+                  <a:ea typeface="Pretendard GOV" panose="02000503000000020004" pitchFamily="2" charset="-127"/>
+                  <a:cs typeface="Pretendard GOV" panose="02000503000000020004" pitchFamily="2" charset="-127"/>
                 </a:rPr>
                 <a:t>Active_Assignment_</a:t>
               </a:r>
@@ -5011,9 +5011,9 @@
                   <a:solidFill>
                     <a:srgbClr val="FFFFFF"/>
                   </a:solidFill>
-                  <a:latin typeface="Pretendard GOV" pitchFamily="34" charset="0"/>
-                  <a:ea typeface="Pretendard GOV" pitchFamily="34" charset="-122"/>
-                  <a:cs typeface="Pretendard GOV" pitchFamily="34" charset="-120"/>
+                  <a:latin typeface="Pretendard GOV" panose="02000503000000020004" pitchFamily="2" charset="-127"/>
+                  <a:ea typeface="Pretendard GOV" panose="02000503000000020004" pitchFamily="2" charset="-127"/>
+                  <a:cs typeface="Pretendard GOV" panose="02000503000000020004" pitchFamily="2" charset="-127"/>
                 </a:rPr>
                 <a:t>CloseOppty_ba</a:t>
               </a:r>
@@ -5077,9 +5077,9 @@
                   <a:solidFill>
                     <a:srgbClr val="FFFFFF"/>
                   </a:solidFill>
-                  <a:latin typeface="Pretendard GOV" pitchFamily="34" charset="0"/>
-                  <a:ea typeface="Pretendard GOV" pitchFamily="34" charset="-122"/>
-                  <a:cs typeface="Pretendard GOV" pitchFamily="34" charset="-120"/>
+                  <a:latin typeface="Pretendard GOV" panose="02000503000000020004" pitchFamily="2" charset="-127"/>
+                  <a:ea typeface="Pretendard GOV" panose="02000503000000020004" pitchFamily="2" charset="-127"/>
+                  <a:cs typeface="Pretendard GOV" panose="02000503000000020004" pitchFamily="2" charset="-127"/>
                 </a:rPr>
                 <a:t>Account_tr</a:t>
               </a:r>
@@ -5094,9 +5094,9 @@
                   <a:solidFill>
                     <a:srgbClr val="FFFFFF"/>
                   </a:solidFill>
-                  <a:latin typeface="Pretendard GOV" pitchFamily="34" charset="0"/>
-                  <a:ea typeface="Pretendard GOV" pitchFamily="34" charset="-122"/>
-                  <a:cs typeface="Pretendard GOV" pitchFamily="34" charset="-120"/>
+                  <a:latin typeface="Pretendard GOV" panose="02000503000000020004" pitchFamily="2" charset="-127"/>
+                  <a:ea typeface="Pretendard GOV" panose="02000503000000020004" pitchFamily="2" charset="-127"/>
+                  <a:cs typeface="Pretendard GOV" panose="02000503000000020004" pitchFamily="2" charset="-127"/>
                 </a:rPr>
                 <a:t>Trigger · real-time</a:t>
               </a:r>
@@ -5133,9 +5133,9 @@
                   <a:solidFill>
                     <a:srgbClr val="D9822B"/>
                   </a:solidFill>
-                  <a:latin typeface="Pretendard GOV" pitchFamily="34" charset="0"/>
-                  <a:ea typeface="Pretendard GOV" pitchFamily="34" charset="-122"/>
-                  <a:cs typeface="Pretendard GOV" pitchFamily="34" charset="-120"/>
+                  <a:latin typeface="Pretendard GOV" panose="02000503000000020004" pitchFamily="2" charset="-127"/>
+                  <a:ea typeface="Pretendard GOV" panose="02000503000000020004" pitchFamily="2" charset="-127"/>
+                  <a:cs typeface="Pretendard GOV" panose="02000503000000020004" pitchFamily="2" charset="-127"/>
                 </a:rPr>
                 <a:t>First order → instant Won</a:t>
               </a:r>
@@ -5199,9 +5199,9 @@
                   <a:solidFill>
                     <a:srgbClr val="FFFFFF"/>
                   </a:solidFill>
-                  <a:latin typeface="Pretendard GOV" pitchFamily="34" charset="0"/>
-                  <a:ea typeface="Pretendard GOV" pitchFamily="34" charset="-122"/>
-                  <a:cs typeface="Pretendard GOV" pitchFamily="34" charset="-120"/>
+                  <a:latin typeface="Pretendard GOV" panose="02000503000000020004" pitchFamily="2" charset="-127"/>
+                  <a:ea typeface="Pretendard GOV" panose="02000503000000020004" pitchFamily="2" charset="-127"/>
+                  <a:cs typeface="Pretendard GOV" panose="02000503000000020004" pitchFamily="2" charset="-127"/>
                 </a:rPr>
                 <a:t>Opportunity (New)</a:t>
               </a:r>
@@ -5216,9 +5216,9 @@
                   <a:solidFill>
                     <a:srgbClr val="FFFFFF"/>
                   </a:solidFill>
-                  <a:latin typeface="Pretendard GOV" pitchFamily="34" charset="0"/>
-                  <a:ea typeface="Pretendard GOV" pitchFamily="34" charset="-122"/>
-                  <a:cs typeface="Pretendard GOV" pitchFamily="34" charset="-120"/>
+                  <a:latin typeface="Pretendard GOV" panose="02000503000000020004" pitchFamily="2" charset="-127"/>
+                  <a:ea typeface="Pretendard GOV" panose="02000503000000020004" pitchFamily="2" charset="-127"/>
+                  <a:cs typeface="Pretendard GOV" panose="02000503000000020004" pitchFamily="2" charset="-127"/>
                 </a:rPr>
                 <a:t>SSR-Active 2 · In Process · +21d</a:t>
               </a:r>
@@ -5282,9 +5282,9 @@
                   <a:solidFill>
                     <a:srgbClr val="1F2A44"/>
                   </a:solidFill>
-                  <a:latin typeface="Pretendard GOV" pitchFamily="34" charset="0"/>
-                  <a:ea typeface="Pretendard GOV" pitchFamily="34" charset="-122"/>
-                  <a:cs typeface="Pretendard GOV" pitchFamily="34" charset="-120"/>
+                  <a:latin typeface="Pretendard GOV" panose="02000503000000020004" pitchFamily="2" charset="-127"/>
+                  <a:ea typeface="Pretendard GOV" panose="02000503000000020004" pitchFamily="2" charset="-127"/>
+                  <a:cs typeface="Pretendard GOV" panose="02000503000000020004" pitchFamily="2" charset="-127"/>
                 </a:rPr>
                 <a:t>Account Owner Update</a:t>
               </a:r>
@@ -5348,9 +5348,9 @@
                   <a:solidFill>
                     <a:srgbClr val="1F2A44"/>
                   </a:solidFill>
-                  <a:latin typeface="Pretendard GOV" pitchFamily="34" charset="0"/>
-                  <a:ea typeface="Pretendard GOV" pitchFamily="34" charset="-122"/>
-                  <a:cs typeface="Pretendard GOV" pitchFamily="34" charset="-120"/>
+                  <a:latin typeface="Pretendard GOV" panose="02000503000000020004" pitchFamily="2" charset="-127"/>
+                  <a:ea typeface="Pretendard GOV" panose="02000503000000020004" pitchFamily="2" charset="-127"/>
+                  <a:cs typeface="Pretendard GOV" panose="02000503000000020004" pitchFamily="2" charset="-127"/>
                 </a:rPr>
                 <a:t>Email Report</a:t>
               </a:r>
@@ -5414,9 +5414,9 @@
                   <a:solidFill>
                     <a:srgbClr val="FFFFFF"/>
                   </a:solidFill>
-                  <a:latin typeface="Pretendard GOV" pitchFamily="34" charset="0"/>
-                  <a:ea typeface="Pretendard GOV" pitchFamily="34" charset="-122"/>
-                  <a:cs typeface="Pretendard GOV" pitchFamily="34" charset="-120"/>
+                  <a:latin typeface="Pretendard GOV" panose="02000503000000020004" pitchFamily="2" charset="-127"/>
+                  <a:ea typeface="Pretendard GOV" panose="02000503000000020004" pitchFamily="2" charset="-127"/>
+                  <a:cs typeface="Pretendard GOV" panose="02000503000000020004" pitchFamily="2" charset="-127"/>
                 </a:rPr>
                 <a:t>Closed Won</a:t>
               </a:r>
@@ -5431,9 +5431,9 @@
                   <a:solidFill>
                     <a:srgbClr val="FFFFFF"/>
                   </a:solidFill>
-                  <a:latin typeface="Pretendard GOV" pitchFamily="34" charset="0"/>
-                  <a:ea typeface="Pretendard GOV" pitchFamily="34" charset="-122"/>
-                  <a:cs typeface="Pretendard GOV" pitchFamily="34" charset="-120"/>
+                  <a:latin typeface="Pretendard GOV" panose="02000503000000020004" pitchFamily="2" charset="-127"/>
+                  <a:ea typeface="Pretendard GOV" panose="02000503000000020004" pitchFamily="2" charset="-127"/>
+                  <a:cs typeface="Pretendard GOV" panose="02000503000000020004" pitchFamily="2" charset="-127"/>
                 </a:rPr>
                 <a:t>first order</a:t>
               </a:r>
@@ -5497,9 +5497,9 @@
                   <a:solidFill>
                     <a:srgbClr val="FFFFFF"/>
                   </a:solidFill>
-                  <a:latin typeface="Pretendard GOV" pitchFamily="34" charset="0"/>
-                  <a:ea typeface="Pretendard GOV" pitchFamily="34" charset="-122"/>
-                  <a:cs typeface="Pretendard GOV" pitchFamily="34" charset="-120"/>
+                  <a:latin typeface="Pretendard GOV" panose="02000503000000020004" pitchFamily="2" charset="-127"/>
+                  <a:ea typeface="Pretendard GOV" panose="02000503000000020004" pitchFamily="2" charset="-127"/>
+                  <a:cs typeface="Pretendard GOV" panose="02000503000000020004" pitchFamily="2" charset="-127"/>
                 </a:rPr>
                 <a:t>Closed Lost</a:t>
               </a:r>
@@ -5514,9 +5514,9 @@
                   <a:solidFill>
                     <a:srgbClr val="FFFFFF"/>
                   </a:solidFill>
-                  <a:latin typeface="Pretendard GOV" pitchFamily="34" charset="0"/>
-                  <a:ea typeface="Pretendard GOV" pitchFamily="34" charset="-122"/>
-                  <a:cs typeface="Pretendard GOV" pitchFamily="34" charset="-120"/>
+                  <a:latin typeface="Pretendard GOV" panose="02000503000000020004" pitchFamily="2" charset="-127"/>
+                  <a:ea typeface="Pretendard GOV" panose="02000503000000020004" pitchFamily="2" charset="-127"/>
+                  <a:cs typeface="Pretendard GOV" panose="02000503000000020004" pitchFamily="2" charset="-127"/>
                 </a:rPr>
                 <a:t>after 21 days</a:t>
               </a:r>
@@ -5695,9 +5695,9 @@
                   <a:solidFill>
                     <a:srgbClr val="2F6DB5"/>
                   </a:solidFill>
-                  <a:latin typeface="Pretendard GOV" pitchFamily="34" charset="0"/>
-                  <a:ea typeface="Pretendard GOV" pitchFamily="34" charset="-122"/>
-                  <a:cs typeface="Pretendard GOV" pitchFamily="34" charset="-120"/>
+                  <a:latin typeface="Pretendard GOV" panose="02000503000000020004" pitchFamily="2" charset="-127"/>
+                  <a:ea typeface="Pretendard GOV" panose="02000503000000020004" pitchFamily="2" charset="-127"/>
+                  <a:cs typeface="Pretendard GOV" panose="02000503000000020004" pitchFamily="2" charset="-127"/>
                 </a:rPr>
                 <a:t>Create · Assign</a:t>
               </a:r>
@@ -5806,9 +5806,9 @@
                   <a:solidFill>
                     <a:srgbClr val="2F6DB5"/>
                   </a:solidFill>
-                  <a:latin typeface="Pretendard GOV" pitchFamily="34" charset="0"/>
-                  <a:ea typeface="Pretendard GOV" pitchFamily="34" charset="-122"/>
-                  <a:cs typeface="Pretendard GOV" pitchFamily="34" charset="-120"/>
+                  <a:latin typeface="Pretendard GOV" panose="02000503000000020004" pitchFamily="2" charset="-127"/>
+                  <a:ea typeface="Pretendard GOV" panose="02000503000000020004" pitchFamily="2" charset="-127"/>
+                  <a:cs typeface="Pretendard GOV" panose="02000503000000020004" pitchFamily="2" charset="-127"/>
                 </a:rPr>
                 <a:t>Close by first order / Close Date</a:t>
               </a:r>
@@ -5919,9 +5919,9 @@
                   <a:solidFill>
                     <a:srgbClr val="374151"/>
                   </a:solidFill>
-                  <a:latin typeface="Pretendard GOV" pitchFamily="34" charset="0"/>
-                  <a:ea typeface="Pretendard GOV" pitchFamily="34" charset="-122"/>
-                  <a:cs typeface="Pretendard GOV" pitchFamily="34" charset="-120"/>
+                  <a:latin typeface="Pretendard GOV" panose="02000503000000020004" pitchFamily="2" charset="-127"/>
+                  <a:ea typeface="Pretendard GOV" panose="02000503000000020004" pitchFamily="2" charset="-127"/>
+                  <a:cs typeface="Pretendard GOV" panose="02000503000000020004" pitchFamily="2" charset="-127"/>
                 </a:rPr>
                 <a:t>Batch flow (daily)</a:t>
               </a:r>
@@ -5981,9 +5981,9 @@
                   <a:solidFill>
                     <a:srgbClr val="374151"/>
                   </a:solidFill>
-                  <a:latin typeface="Pretendard GOV" pitchFamily="34" charset="0"/>
-                  <a:ea typeface="Pretendard GOV" pitchFamily="34" charset="-122"/>
-                  <a:cs typeface="Pretendard GOV" pitchFamily="34" charset="-120"/>
+                  <a:latin typeface="Pretendard GOV" panose="02000503000000020004" pitchFamily="2" charset="-127"/>
+                  <a:ea typeface="Pretendard GOV" panose="02000503000000020004" pitchFamily="2" charset="-127"/>
+                  <a:cs typeface="Pretendard GOV" panose="02000503000000020004" pitchFamily="2" charset="-127"/>
                 </a:rPr>
                 <a:t>Trigger flow (real-time)</a:t>
               </a:r>

</xml_diff>